<commit_message>
PPT v3 수정: 표지 라인 제거, slide 2/4/8 문구 정리, slide 5 figure 크기 조정
Co-Authored-By: Claude Sonnet 4.6 <noreply@anthropic.com>
</commit_message>
<xml_diff>
--- a/outputs/presentations/smartpitch_v3.pptx
+++ b/outputs/presentations/smartpitch_v3.pptx
@@ -3143,50 +3143,7 @@
       </p:sp>
       <p:sp>
         <p:nvSpPr>
-          <p:cNvPr id="3" name="Rectangle 2"/>
-          <p:cNvSpPr/>
-          <p:nvPr/>
-        </p:nvSpPr>
-        <p:spPr>
-          <a:xfrm>
-            <a:off x="0" y="2743200"/>
-            <a:ext cx="12191695" cy="54864"/>
-          </a:xfrm>
-          <a:prstGeom prst="rect">
-            <a:avLst/>
-          </a:prstGeom>
-          <a:solidFill>
-            <a:srgbClr val="E67E22"/>
-          </a:solidFill>
-          <a:ln>
-            <a:noFill/>
-          </a:ln>
-        </p:spPr>
-        <p:style>
-          <a:lnRef idx="1">
-            <a:schemeClr val="accent1"/>
-          </a:lnRef>
-          <a:fillRef idx="3">
-            <a:schemeClr val="accent1"/>
-          </a:fillRef>
-          <a:effectRef idx="2">
-            <a:schemeClr val="accent1"/>
-          </a:effectRef>
-          <a:fontRef idx="minor">
-            <a:schemeClr val="lt1"/>
-          </a:fontRef>
-        </p:style>
-        <p:txBody>
-          <a:bodyPr rtlCol="0" anchor="ctr"/>
-          <a:lstStyle/>
-          <a:p>
-            <a:pPr algn="ctr"/>
-          </a:p>
-        </p:txBody>
-      </p:sp>
-      <p:sp>
-        <p:nvSpPr>
-          <p:cNvPr id="4" name="TextBox 3"/>
+          <p:cNvPr id="3" name="TextBox 2"/>
           <p:cNvSpPr txBox="1"/>
           <p:nvPr/>
         </p:nvSpPr>
@@ -3221,7 +3178,7 @@
       </p:sp>
       <p:sp>
         <p:nvSpPr>
-          <p:cNvPr id="5" name="TextBox 4"/>
+          <p:cNvPr id="4" name="TextBox 3"/>
           <p:cNvSpPr txBox="1"/>
           <p:nvPr/>
         </p:nvSpPr>
@@ -3268,7 +3225,7 @@
       </p:sp>
       <p:sp>
         <p:nvSpPr>
-          <p:cNvPr id="6" name="TextBox 5"/>
+          <p:cNvPr id="5" name="TextBox 4"/>
           <p:cNvSpPr txBox="1"/>
           <p:nvPr/>
         </p:nvSpPr>
@@ -4985,7 +4942,7 @@
                 </a:solidFill>
                 <a:latin typeface="맑은 고딕"/>
               </a:rPr>
-              <a:t>재고: 단기 예측 정확도 vs. 장기 전략 보상 최적화</a:t>
+              <a:t>참고: 단기 예측 정확도 vs. 장기 전략 보상 최적화</a:t>
             </a:r>
           </a:p>
         </p:txBody>
@@ -5201,7 +5158,7 @@
                 </a:solidFill>
                 <a:latin typeface="맑은 고딕"/>
               </a:rPr>
-              <a:t>Pitcher Arsenal 정보가 Sequence 모델을 대체할 수 있다</a:t>
+              <a:t>핵심 발견: Arsenal feature의 효과</a:t>
             </a:r>
           </a:p>
         </p:txBody>
@@ -5377,8 +5334,8 @@
         </p:blipFill>
         <p:spPr>
           <a:xfrm>
-            <a:off x="914377" y="960120"/>
-            <a:ext cx="10362940" cy="7024700"/>
+            <a:off x="2386310" y="1005840"/>
+            <a:ext cx="7419075" cy="5029200"/>
           </a:xfrm>
           <a:prstGeom prst="rect">
             <a:avLst/>
@@ -5393,7 +5350,7 @@
         </p:nvSpPr>
         <p:spPr>
           <a:xfrm>
-            <a:off x="457200" y="6446520"/>
+            <a:off x="457200" y="6144768"/>
             <a:ext cx="11277295" cy="457200"/>
           </a:xfrm>
           <a:prstGeom prst="rect">
@@ -6783,7 +6740,7 @@
         <p:spPr>
           <a:xfrm>
             <a:off x="457200" y="1188720"/>
-            <a:ext cx="11277295" cy="548640"/>
+            <a:ext cx="11277295" cy="2560320"/>
           </a:xfrm>
           <a:prstGeom prst="rect">
             <a:avLst/>
@@ -6807,29 +6764,18 @@
               <a:t>• Phase 4.4: Model C 환경에서 RL 재실험 (Transformer 전이확률 활용)</a:t>
             </a:r>
           </a:p>
-        </p:txBody>
-      </p:sp>
-      <p:sp>
-        <p:nvSpPr>
-          <p:cNvPr id="5" name="TextBox 4"/>
-          <p:cNvSpPr txBox="1"/>
-          <p:nvPr/>
-        </p:nvSpPr>
-        <p:spPr>
-          <a:xfrm>
-            <a:off x="457200" y="1828800"/>
-            <a:ext cx="11277295" cy="548640"/>
-          </a:xfrm>
-          <a:prstGeom prst="rect">
-            <a:avLst/>
-          </a:prstGeom>
-          <a:noFill/>
-        </p:spPr>
-        <p:txBody>
-          <a:bodyPr wrap="square">
-            <a:spAutoFit/>
-          </a:bodyPr>
-          <a:lstStyle/>
+          <a:p>
+            <a:pPr algn="l"/>
+            <a:r>
+              <a:rPr sz="2000" b="0" i="0">
+                <a:solidFill>
+                  <a:srgbClr val="2C3E50"/>
+                </a:solidFill>
+                <a:latin typeface="맑은 고딕"/>
+              </a:rPr>
+              <a:t/>
+            </a:r>
+          </a:p>
           <a:p>
             <a:pPr algn="l"/>
             <a:r>
@@ -6842,29 +6788,18 @@
               <a:t>• Hit location 예측 추가 (MIT Sloan 참고 — 9-class hit location)</a:t>
             </a:r>
           </a:p>
-        </p:txBody>
-      </p:sp>
-      <p:sp>
-        <p:nvSpPr>
-          <p:cNvPr id="6" name="TextBox 5"/>
-          <p:cNvSpPr txBox="1"/>
-          <p:nvPr/>
-        </p:nvSpPr>
-        <p:spPr>
-          <a:xfrm>
-            <a:off x="457200" y="2468880"/>
-            <a:ext cx="11277295" cy="548640"/>
-          </a:xfrm>
-          <a:prstGeom prst="rect">
-            <a:avLst/>
-          </a:prstGeom>
-          <a:noFill/>
-        </p:spPr>
-        <p:txBody>
-          <a:bodyPr wrap="square">
-            <a:spAutoFit/>
-          </a:bodyPr>
-          <a:lstStyle/>
+          <a:p>
+            <a:pPr algn="l"/>
+            <a:r>
+              <a:rPr sz="2000" b="0" i="0">
+                <a:solidFill>
+                  <a:srgbClr val="2C3E50"/>
+                </a:solidFill>
+                <a:latin typeface="맑은 고딕"/>
+              </a:rPr>
+              <a:t/>
+            </a:r>
+          </a:p>
           <a:p>
             <a:pPr algn="l"/>
             <a:r>
@@ -6881,7 +6816,7 @@
       </p:sp>
       <p:sp>
         <p:nvSpPr>
-          <p:cNvPr id="7" name="Rectangle 6"/>
+          <p:cNvPr id="5" name="Rectangle 4"/>
           <p:cNvSpPr/>
           <p:nvPr/>
         </p:nvSpPr>
@@ -6924,7 +6859,7 @@
       </p:sp>
       <p:sp>
         <p:nvSpPr>
-          <p:cNvPr id="8" name="TextBox 7"/>
+          <p:cNvPr id="6" name="TextBox 5"/>
           <p:cNvSpPr txBox="1"/>
           <p:nvPr/>
         </p:nvSpPr>

</xml_diff>

<commit_message>
수치 표기 통일: arsenal 52d → context 58d (count_cluster_id 1d 누락 오기 수정)
- CLAUDE.md, docs/paper_comparison.md: 52d/53d → 58d 전면 교체
- scripts/22_build_presentation.py: slide 4/7 캡션 3곳 수정
- notebooks/13_presentation_figures.ipynb: Figure 1 bar label, Figure 2 셀 텍스트 + 하단 결론
- PNG/PPTX 재생성: fig1, fig2, smartpitch_v3.pptx

Co-Authored-By: Claude Sonnet 4.6 <noreply@anthropic.com>
</commit_message>
<xml_diff>
--- a/outputs/presentations/smartpitch_v3.pptx
+++ b/outputs/presentations/smartpitch_v3.pptx
@@ -5217,7 +5217,7 @@
                 </a:solidFill>
                 <a:latin typeface="맑은 고딕"/>
               </a:rPr>
-              <a:t>조건 통제 검증: Focal Loss γ=2.0 동일 적용 — arsenal feature 52d 추가만으로 +26.5pp</a:t>
+              <a:t>조건 통제 검증: Focal Loss γ=2.0 동일 적용 — context 58d 추가만으로 +26.5pp</a:t>
             </a:r>
           </a:p>
         </p:txBody>
@@ -6515,7 +6515,7 @@
                 </a:solidFill>
                 <a:latin typeface="맑은 고딕"/>
               </a:rPr>
-              <a:t>MIT Sloan: Transformer 필수 (MDP 비호환)  →  본인 MLP + arsenal 52d: 동등 성능 + MDP 호환</a:t>
+              <a:t>MIT Sloan: Transformer 필수 (MDP 비호환)  →  본인 MLP + context 58d: 동등 성능 + MDP 호환</a:t>
             </a:r>
           </a:p>
         </p:txBody>
@@ -6630,7 +6630,7 @@
                 </a:solidFill>
                 <a:latin typeface="맑은 고딕"/>
               </a:rPr>
-              <a:t>arsenal 52d 추가  →  +26.5pp 정량 검증  (77d 41.1% → 135d 67.6%)</a:t>
+              <a:t>context 58d 추가  →  +26.5pp 정량 검증  (77d 41.1% → 135d 67.6%)</a:t>
             </a:r>
           </a:p>
         </p:txBody>

</xml_diff>